<commit_message>
refactor: optimize project structure and presentation script for 2-member team
</commit_message>
<xml_diff>
--- a/Design Thinking Poster.pptx
+++ b/Design Thinking Poster.pptx
@@ -13056,7 +13056,7 @@
               </a:defRPr>
             </a:pPr>
             <a:r>
-              <a:t>Team Members: [Member 1 | Member 2 | Member 3 | Member 4]  •  Reg Nos: [2309xxxxx | 2309xxxxx | 2309xxxxx | 2309xxxxx]</a:t>
+              <a:t>Team Members: [Team Member 1 | Team Member 2]  •  Reg Nos: [2309xxxxx | 2309xxxxx]</a:t>
             </a:r>
           </a:p>
           <a:p>
@@ -25456,6 +25456,855 @@
       <p:sp>
         <p:nvSpPr>
           <p:cNvPr id="256" name="Rounded Rectangle 255"/>
+          <p:cNvSpPr/>
+          <p:nvPr/>
+        </p:nvSpPr>
+        <p:spPr>
+          <a:xfrm>
+            <a:off x="18500000" y="28500000"/>
+            <a:ext cx="16500000" cy="6800000"/>
+          </a:xfrm>
+          <a:prstGeom prst="roundRect">
+            <a:avLst/>
+          </a:prstGeom>
+          <a:solidFill>
+            <a:srgbClr val="FFFFFF"/>
+          </a:solidFill>
+          <a:ln w="25400">
+            <a:solidFill>
+              <a:srgbClr val="CBD5E1"/>
+            </a:solidFill>
+          </a:ln>
+        </p:spPr>
+        <p:style>
+          <a:lnRef idx="1">
+            <a:schemeClr val="accent1"/>
+          </a:lnRef>
+          <a:fillRef idx="3">
+            <a:schemeClr val="accent1"/>
+          </a:fillRef>
+          <a:effectRef idx="2">
+            <a:schemeClr val="accent1"/>
+          </a:effectRef>
+          <a:fontRef idx="minor">
+            <a:schemeClr val="lt1"/>
+          </a:fontRef>
+        </p:style>
+        <p:txBody>
+          <a:bodyPr rtlCol="0" anchor="ctr" wrap="square" lIns="182880" tIns="182880" rIns="182880" bIns="182880"/>
+          <a:lstStyle/>
+          <a:p>
+            <a:pPr algn="ctr">
+              <a:spcAft>
+                <a:spcPts val="1200"/>
+              </a:spcAft>
+              <a:defRPr sz="2200" b="1">
+                <a:solidFill>
+                  <a:srgbClr val="2563EB"/>
+                </a:solidFill>
+              </a:defRPr>
+            </a:pPr>
+            <a:r>
+              <a:t>OUTCOME &amp; IMPACT</a:t>
+            </a:r>
+          </a:p>
+          <a:p>
+            <a:pPr>
+              <a:spcAft>
+                <a:spcPts val="800"/>
+              </a:spcAft>
+              <a:defRPr sz="1500">
+                <a:solidFill>
+                  <a:srgbClr val="0F172A"/>
+                </a:solidFill>
+              </a:defRPr>
+            </a:pPr>
+            <a:r>
+              <a:t>•  Peer Walkthrough &amp; Thematic Validation:</a:t>
+            </a:r>
+          </a:p>
+          <a:p>
+            <a:pPr>
+              <a:spcAft>
+                <a:spcPts val="800"/>
+              </a:spcAft>
+              <a:defRPr sz="1500">
+                <a:solidFill>
+                  <a:srgbClr val="0F172A"/>
+                </a:solidFill>
+              </a:defRPr>
+            </a:pPr>
+            <a:r>
+              <a:t>•    • Zero-Knowledge Safety: Female hostel students praised complete concealment of phone numbers &amp; room details.</a:t>
+            </a:r>
+          </a:p>
+          <a:p>
+            <a:pPr>
+              <a:spcAft>
+                <a:spcPts val="800"/>
+              </a:spcAft>
+              <a:defRPr sz="1500">
+                <a:solidFill>
+                  <a:srgbClr val="0F172A"/>
+                </a:solidFill>
+              </a:defRPr>
+            </a:pPr>
+            <a:r>
+              <a:t>•    • On-Spot UPI Trust: Direct scan-and-pay eliminates fear of advance app escrow lock-in.</a:t>
+            </a:r>
+          </a:p>
+          <a:p>
+            <a:pPr>
+              <a:spcAft>
+                <a:spcPts val="800"/>
+              </a:spcAft>
+              <a:defRPr sz="1500">
+                <a:solidFill>
+                  <a:srgbClr val="0F172A"/>
+                </a:solidFill>
+              </a:defRPr>
+            </a:pPr>
+            <a:r>
+              <a:t>•    • Transparent Fixed Pricing: Freshers confirmed total relief from opaque 'DM for price' culture.</a:t>
+            </a:r>
+          </a:p>
+          <a:p>
+            <a:pPr>
+              <a:spcAft>
+                <a:spcPts val="800"/>
+              </a:spcAft>
+              <a:defRPr sz="1500">
+                <a:solidFill>
+                  <a:srgbClr val="0F172A"/>
+                </a:solidFill>
+              </a:defRPr>
+            </a:pPr>
+            <a:r>
+              <a:t>•  Campus Impact: Prevents recurring spending on 1-semester gear and recirculates idle resources within MIT Bengaluru.</a:t>
+            </a:r>
+          </a:p>
+          <a:p>
+            <a:pPr>
+              <a:spcAft>
+                <a:spcPts val="800"/>
+              </a:spcAft>
+              <a:defRPr sz="1500">
+                <a:solidFill>
+                  <a:srgbClr val="0F172A"/>
+                </a:solidFill>
+              </a:defRPr>
+            </a:pPr>
+            <a:r>
+              <a:t>•  Future Roadmap: WhatsApp Cloud API alerts, campus locker integration, and library reserve sync.</a:t>
+            </a:r>
+          </a:p>
+        </p:txBody>
+      </p:sp>
+      <p:sp>
+        <p:nvSpPr>
+          <p:cNvPr id="257" name="Rounded Rectangle 256"/>
+          <p:cNvSpPr/>
+          <p:nvPr/>
+        </p:nvSpPr>
+        <p:spPr>
+          <a:xfrm>
+            <a:off x="1000000" y="5800000"/>
+            <a:ext cx="16500000" cy="19000000"/>
+          </a:xfrm>
+          <a:prstGeom prst="roundRect">
+            <a:avLst/>
+          </a:prstGeom>
+          <a:solidFill>
+            <a:srgbClr val="FFFFFF"/>
+          </a:solidFill>
+          <a:ln w="25400">
+            <a:solidFill>
+              <a:srgbClr val="CBD5E1"/>
+            </a:solidFill>
+          </a:ln>
+        </p:spPr>
+        <p:style>
+          <a:lnRef idx="1">
+            <a:schemeClr val="accent1"/>
+          </a:lnRef>
+          <a:fillRef idx="3">
+            <a:schemeClr val="accent1"/>
+          </a:fillRef>
+          <a:effectRef idx="2">
+            <a:schemeClr val="accent1"/>
+          </a:effectRef>
+          <a:fontRef idx="minor">
+            <a:schemeClr val="lt1"/>
+          </a:fontRef>
+        </p:style>
+        <p:txBody>
+          <a:bodyPr rtlCol="0" anchor="ctr" wrap="square" lIns="182880" tIns="182880" rIns="182880" bIns="182880"/>
+          <a:lstStyle/>
+          <a:p>
+            <a:pPr algn="ctr">
+              <a:spcAft>
+                <a:spcPts val="1200"/>
+              </a:spcAft>
+              <a:defRPr sz="2200" b="1">
+                <a:solidFill>
+                  <a:srgbClr val="2563EB"/>
+                </a:solidFill>
+              </a:defRPr>
+            </a:pPr>
+            <a:r>
+              <a:t>PHASE 1: EMPATHY &amp; OBJECTIVE</a:t>
+            </a:r>
+          </a:p>
+          <a:p>
+            <a:pPr>
+              <a:spcAft>
+                <a:spcPts val="800"/>
+              </a:spcAft>
+              <a:defRPr sz="1500">
+                <a:solidFill>
+                  <a:srgbClr val="0F172A"/>
+                </a:solidFill>
+              </a:defRPr>
+            </a:pPr>
+            <a:r>
+              <a:t>•  Project Objective: Create a zero-friction, verified circular exchange platform allowing engineering students to Borrow, Rent, or Buy single-semester academic gear (textbooks, Casio fx-991 calculators, lab coats, drafters) from seniors at near-zero cost.</a:t>
+            </a:r>
+          </a:p>
+          <a:p>
+            <a:pPr>
+              <a:spcAft>
+                <a:spcPts val="800"/>
+              </a:spcAft>
+              <a:defRPr sz="1500">
+                <a:solidFill>
+                  <a:srgbClr val="0F172A"/>
+                </a:solidFill>
+              </a:defRPr>
+            </a:pPr>
+            <a:r>
+              <a:t>•  Qualitative Field Insights (MIT Bengaluru Campus):</a:t>
+            </a:r>
+          </a:p>
+          <a:p>
+            <a:pPr>
+              <a:spcAft>
+                <a:spcPts val="800"/>
+              </a:spcAft>
+              <a:defRPr sz="1500">
+                <a:solidFill>
+                  <a:srgbClr val="0F172A"/>
+                </a:solidFill>
+              </a:defRPr>
+            </a:pPr>
+            <a:r>
+              <a:t>•    - 88% of freshers spend ₹2,500–₹4,500 every semester on specialized gear used for only 16 weeks.</a:t>
+            </a:r>
+          </a:p>
+          <a:p>
+            <a:pPr>
+              <a:spcAft>
+                <a:spcPts val="800"/>
+              </a:spcAft>
+              <a:defRPr sz="1500">
+                <a:solidFill>
+                  <a:srgbClr val="0F172A"/>
+                </a:solidFill>
+              </a:defRPr>
+            </a:pPr>
+            <a:r>
+              <a:t>•    - 92% of seniors have 3+ textbooks &amp; tools sitting idle in hostel cupboards with no easy way to transfer them.</a:t>
+            </a:r>
+          </a:p>
+          <a:p>
+            <a:pPr>
+              <a:spcAft>
+                <a:spcPts val="800"/>
+              </a:spcAft>
+              <a:defRPr sz="1500">
+                <a:solidFill>
+                  <a:srgbClr val="0F172A"/>
+                </a:solidFill>
+              </a:defRPr>
+            </a:pPr>
+            <a:r>
+              <a:t>•    - Existing WhatsApp groups fail: notices get buried under hundreds of messages within 15 minutes.</a:t>
+            </a:r>
+          </a:p>
+          <a:p>
+            <a:pPr>
+              <a:spcAft>
+                <a:spcPts val="800"/>
+              </a:spcAft>
+              <a:defRPr sz="1500">
+                <a:solidFill>
+                  <a:srgbClr val="0F172A"/>
+                </a:solidFill>
+              </a:defRPr>
+            </a:pPr>
+            <a:r>
+              <a:t>•  Customer Journey Mapping Highlights:</a:t>
+            </a:r>
+          </a:p>
+          <a:p>
+            <a:pPr>
+              <a:spcAft>
+                <a:spcPts val="800"/>
+              </a:spcAft>
+              <a:defRPr sz="1500">
+                <a:solidFill>
+                  <a:srgbClr val="0F172A"/>
+                </a:solidFill>
+              </a:defRPr>
+            </a:pPr>
+            <a:r>
+              <a:t>•    - Touchpoints: Syllabus release -&gt; WhatsApp panic -&gt; Senior negotiation -&gt; Handover friction -&gt; Disposal.</a:t>
+            </a:r>
+          </a:p>
+          <a:p>
+            <a:pPr>
+              <a:spcAft>
+                <a:spcPts val="800"/>
+              </a:spcAft>
+              <a:defRPr sz="1500">
+                <a:solidFill>
+                  <a:srgbClr val="0F172A"/>
+                </a:solidFill>
+              </a:defRPr>
+            </a:pPr>
+            <a:r>
+              <a:t>•    - Emotional Dip: High anxiety during 1st month due to unexpected equipment expenses.</a:t>
+            </a:r>
+          </a:p>
+          <a:p>
+            <a:pPr>
+              <a:spcAft>
+                <a:spcPts val="800"/>
+              </a:spcAft>
+              <a:defRPr sz="1500">
+                <a:solidFill>
+                  <a:srgbClr val="0F172A"/>
+                </a:solidFill>
+              </a:defRPr>
+            </a:pPr>
+            <a:r>
+              <a:t>•  Problem Statement: Freshers face recurring financial burdens while seniors hoard unused academic supplies, caused by the absence of a structured, campus-verified peer-to-peer exchange.</a:t>
+            </a:r>
+          </a:p>
+        </p:txBody>
+      </p:sp>
+      <p:sp>
+        <p:nvSpPr>
+          <p:cNvPr id="258" name="Rounded Rectangle 257"/>
+          <p:cNvSpPr/>
+          <p:nvPr/>
+        </p:nvSpPr>
+        <p:spPr>
+          <a:xfrm>
+            <a:off x="1000000" y="26800000"/>
+            <a:ext cx="16500000" cy="8500000"/>
+          </a:xfrm>
+          <a:prstGeom prst="roundRect">
+            <a:avLst/>
+          </a:prstGeom>
+          <a:solidFill>
+            <a:srgbClr val="FFFFFF"/>
+          </a:solidFill>
+          <a:ln w="25400">
+            <a:solidFill>
+              <a:srgbClr val="CBD5E1"/>
+            </a:solidFill>
+          </a:ln>
+        </p:spPr>
+        <p:style>
+          <a:lnRef idx="1">
+            <a:schemeClr val="accent1"/>
+          </a:lnRef>
+          <a:fillRef idx="3">
+            <a:schemeClr val="accent1"/>
+          </a:fillRef>
+          <a:effectRef idx="2">
+            <a:schemeClr val="accent1"/>
+          </a:effectRef>
+          <a:fontRef idx="minor">
+            <a:schemeClr val="lt1"/>
+          </a:fontRef>
+        </p:style>
+        <p:txBody>
+          <a:bodyPr rtlCol="0" anchor="ctr" wrap="square" lIns="182880" tIns="182880" rIns="182880" bIns="182880"/>
+          <a:lstStyle/>
+          <a:p>
+            <a:pPr algn="ctr">
+              <a:spcAft>
+                <a:spcPts val="1200"/>
+              </a:spcAft>
+              <a:defRPr sz="2200" b="1">
+                <a:solidFill>
+                  <a:srgbClr val="2563EB"/>
+                </a:solidFill>
+              </a:defRPr>
+            </a:pPr>
+            <a:r>
+              <a:t>PHASE 2: ANALYSE &amp; ROOT CAUSE</a:t>
+            </a:r>
+          </a:p>
+          <a:p>
+            <a:pPr>
+              <a:spcAft>
+                <a:spcPts val="800"/>
+              </a:spcAft>
+              <a:defRPr sz="1500">
+                <a:solidFill>
+                  <a:srgbClr val="0F172A"/>
+                </a:solidFill>
+              </a:defRPr>
+            </a:pPr>
+            <a:r>
+              <a:t>•  5-Whys Root Cause Analysis:</a:t>
+            </a:r>
+          </a:p>
+          <a:p>
+            <a:pPr>
+              <a:spcAft>
+                <a:spcPts val="800"/>
+              </a:spcAft>
+              <a:defRPr sz="1500">
+                <a:solidFill>
+                  <a:srgbClr val="0F172A"/>
+                </a:solidFill>
+              </a:defRPr>
+            </a:pPr>
+            <a:r>
+              <a:t>•    1. Why do freshers overspend on tools? They buy brand new items from external stores.</a:t>
+            </a:r>
+          </a:p>
+          <a:p>
+            <a:pPr>
+              <a:spcAft>
+                <a:spcPts val="800"/>
+              </a:spcAft>
+              <a:defRPr sz="1500">
+                <a:solidFill>
+                  <a:srgbClr val="0F172A"/>
+                </a:solidFill>
+              </a:defRPr>
+            </a:pPr>
+            <a:r>
+              <a:t>•    2. Why don't they get them from seniors? Unused items remain locked in seniors' hostel rooms.</a:t>
+            </a:r>
+          </a:p>
+          <a:p>
+            <a:pPr>
+              <a:spcAft>
+                <a:spcPts val="800"/>
+              </a:spcAft>
+              <a:defRPr sz="1500">
+                <a:solidFill>
+                  <a:srgbClr val="0F172A"/>
+                </a:solidFill>
+              </a:defRPr>
+            </a:pPr>
+            <a:r>
+              <a:t>•    3. Why don't seniors sell or lend them? Informal posting on social media is cumbersome and unorganized.</a:t>
+            </a:r>
+          </a:p>
+          <a:p>
+            <a:pPr>
+              <a:spcAft>
+                <a:spcPts val="800"/>
+              </a:spcAft>
+              <a:defRPr sz="1500">
+                <a:solidFill>
+                  <a:srgbClr val="0F172A"/>
+                </a:solidFill>
+              </a:defRPr>
+            </a:pPr>
+            <a:r>
+              <a:t>•    4. Why are chat groups inefficient? No search filters, item categories, or availability tracking.</a:t>
+            </a:r>
+          </a:p>
+          <a:p>
+            <a:pPr>
+              <a:spcAft>
+                <a:spcPts val="800"/>
+              </a:spcAft>
+              <a:defRPr sz="1500">
+                <a:solidFill>
+                  <a:srgbClr val="0F172A"/>
+                </a:solidFill>
+              </a:defRPr>
+            </a:pPr>
+            <a:r>
+              <a:t>•    5. Root Cause: Lack of a dedicated, campus-verified web portal facilitating discovery and peer handover.</a:t>
+            </a:r>
+          </a:p>
+          <a:p>
+            <a:pPr>
+              <a:spcAft>
+                <a:spcPts val="800"/>
+              </a:spcAft>
+              <a:defRPr sz="1500">
+                <a:solidFill>
+                  <a:srgbClr val="0F172A"/>
+                </a:solidFill>
+              </a:defRPr>
+            </a:pPr>
+            <a:r>
+              <a:t>•  How Might We (HMW) Question:</a:t>
+            </a:r>
+          </a:p>
+          <a:p>
+            <a:pPr>
+              <a:spcAft>
+                <a:spcPts val="800"/>
+              </a:spcAft>
+              <a:defRPr sz="1500">
+                <a:solidFill>
+                  <a:srgbClr val="0F172A"/>
+                </a:solidFill>
+              </a:defRPr>
+            </a:pPr>
+            <a:r>
+              <a:t>•    'How might we connect junior and senior students for safe, verified, zero-commission exchange of academic resources at designated campus landmarks?'</a:t>
+            </a:r>
+          </a:p>
+        </p:txBody>
+      </p:sp>
+      <p:sp>
+        <p:nvSpPr>
+          <p:cNvPr id="259" name="Rounded Rectangle 258"/>
+          <p:cNvSpPr/>
+          <p:nvPr/>
+        </p:nvSpPr>
+        <p:spPr>
+          <a:xfrm>
+            <a:off x="18500000" y="5800000"/>
+            <a:ext cx="16500000" cy="7200000"/>
+          </a:xfrm>
+          <a:prstGeom prst="roundRect">
+            <a:avLst/>
+          </a:prstGeom>
+          <a:solidFill>
+            <a:srgbClr val="FFFFFF"/>
+          </a:solidFill>
+          <a:ln w="25400">
+            <a:solidFill>
+              <a:srgbClr val="CBD5E1"/>
+            </a:solidFill>
+          </a:ln>
+        </p:spPr>
+        <p:style>
+          <a:lnRef idx="1">
+            <a:schemeClr val="accent1"/>
+          </a:lnRef>
+          <a:fillRef idx="3">
+            <a:schemeClr val="accent1"/>
+          </a:fillRef>
+          <a:effectRef idx="2">
+            <a:schemeClr val="accent1"/>
+          </a:effectRef>
+          <a:fontRef idx="minor">
+            <a:schemeClr val="lt1"/>
+          </a:fontRef>
+        </p:style>
+        <p:txBody>
+          <a:bodyPr rtlCol="0" anchor="ctr" wrap="square" lIns="182880" tIns="182880" rIns="182880" bIns="182880"/>
+          <a:lstStyle/>
+          <a:p>
+            <a:pPr algn="ctr">
+              <a:spcAft>
+                <a:spcPts val="1200"/>
+              </a:spcAft>
+              <a:defRPr sz="2200" b="1">
+                <a:solidFill>
+                  <a:srgbClr val="2563EB"/>
+                </a:solidFill>
+              </a:defRPr>
+            </a:pPr>
+            <a:r>
+              <a:t>PHASE 3: SOLVE &amp; KEY FEATURES</a:t>
+            </a:r>
+          </a:p>
+          <a:p>
+            <a:pPr>
+              <a:spcAft>
+                <a:spcPts val="800"/>
+              </a:spcAft>
+              <a:defRPr sz="1500">
+                <a:solidFill>
+                  <a:srgbClr val="0F172A"/>
+                </a:solidFill>
+              </a:defRPr>
+            </a:pPr>
+            <a:r>
+              <a:t>•  Multi-Tier Exchange Mechanism:</a:t>
+            </a:r>
+          </a:p>
+          <a:p>
+            <a:pPr>
+              <a:spcAft>
+                <a:spcPts val="800"/>
+              </a:spcAft>
+              <a:defRPr sz="1500">
+                <a:solidFill>
+                  <a:srgbClr val="0F172A"/>
+                </a:solidFill>
+              </a:defRPr>
+            </a:pPr>
+            <a:r>
+              <a:t>•    • Borrow (Free): 1-semester loan with return guarantee (e.g. Higher Engg Math).</a:t>
+            </a:r>
+          </a:p>
+          <a:p>
+            <a:pPr>
+              <a:spcAft>
+                <a:spcPts val="800"/>
+              </a:spcAft>
+              <a:defRPr sz="1500">
+                <a:solidFill>
+                  <a:srgbClr val="0F172A"/>
+                </a:solidFill>
+              </a:defRPr>
+            </a:pPr>
+            <a:r>
+              <a:t>•    • Rent (Low-Cost): Weekly rentals (₹20-50/wk) for exam prep (e.g. Casio fx-991).</a:t>
+            </a:r>
+          </a:p>
+          <a:p>
+            <a:pPr>
+              <a:spcAft>
+                <a:spcPts val="800"/>
+              </a:spcAft>
+              <a:defRPr sz="1500">
+                <a:solidFill>
+                  <a:srgbClr val="0F172A"/>
+                </a:solidFill>
+              </a:defRPr>
+            </a:pPr>
+            <a:r>
+              <a:t>•    • Buy (75% Off): Permanent transfer at deep discount (e.g. Mini Drafters, CLRS).</a:t>
+            </a:r>
+          </a:p>
+          <a:p>
+            <a:pPr>
+              <a:spcAft>
+                <a:spcPts val="800"/>
+              </a:spcAft>
+              <a:defRPr sz="1500">
+                <a:solidFill>
+                  <a:srgbClr val="0F172A"/>
+                </a:solidFill>
+              </a:defRPr>
+            </a:pPr>
+            <a:r>
+              <a:t>•  Verified Campus Security: Restricted to @learner.manipal.edu credentials.</a:t>
+            </a:r>
+          </a:p>
+          <a:p>
+            <a:pPr>
+              <a:spcAft>
+                <a:spcPts val="800"/>
+              </a:spcAft>
+              <a:defRPr sz="1500">
+                <a:solidFill>
+                  <a:srgbClr val="0F172A"/>
+                </a:solidFill>
+              </a:defRPr>
+            </a:pPr>
+            <a:r>
+              <a:t>•  Zero Courier Delay: Handovers coordinated at Central Library &amp; Food Court.</a:t>
+            </a:r>
+          </a:p>
+        </p:txBody>
+      </p:sp>
+      <p:sp>
+        <p:nvSpPr>
+          <p:cNvPr id="260" name="Rounded Rectangle 259"/>
+          <p:cNvSpPr/>
+          <p:nvPr/>
+        </p:nvSpPr>
+        <p:spPr>
+          <a:xfrm>
+            <a:off x="18500000" y="14500000"/>
+            <a:ext cx="16500000" cy="12500000"/>
+          </a:xfrm>
+          <a:prstGeom prst="roundRect">
+            <a:avLst/>
+          </a:prstGeom>
+          <a:solidFill>
+            <a:srgbClr val="FFFFFF"/>
+          </a:solidFill>
+          <a:ln w="25400">
+            <a:solidFill>
+              <a:srgbClr val="CBD5E1"/>
+            </a:solidFill>
+          </a:ln>
+        </p:spPr>
+        <p:style>
+          <a:lnRef idx="1">
+            <a:schemeClr val="accent1"/>
+          </a:lnRef>
+          <a:fillRef idx="3">
+            <a:schemeClr val="accent1"/>
+          </a:fillRef>
+          <a:effectRef idx="2">
+            <a:schemeClr val="accent1"/>
+          </a:effectRef>
+          <a:fontRef idx="minor">
+            <a:schemeClr val="lt1"/>
+          </a:fontRef>
+        </p:style>
+        <p:txBody>
+          <a:bodyPr rtlCol="0" anchor="ctr" wrap="square" lIns="182880" tIns="182880" rIns="182880" bIns="182880"/>
+          <a:lstStyle/>
+          <a:p>
+            <a:pPr algn="ctr">
+              <a:spcAft>
+                <a:spcPts val="1200"/>
+              </a:spcAft>
+              <a:defRPr sz="2200" b="1">
+                <a:solidFill>
+                  <a:srgbClr val="2563EB"/>
+                </a:solidFill>
+              </a:defRPr>
+            </a:pPr>
+            <a:r>
+              <a:t>PHASE 4: PROTOTYPE IMPLEMENTATION</a:t>
+            </a:r>
+          </a:p>
+          <a:p>
+            <a:pPr>
+              <a:spcAft>
+                <a:spcPts val="800"/>
+              </a:spcAft>
+              <a:defRPr sz="1500">
+                <a:solidFill>
+                  <a:srgbClr val="0F172A"/>
+                </a:solidFill>
+              </a:defRPr>
+            </a:pPr>
+            <a:r>
+              <a:t>•  Interactive Web Application Built with Semantic HTML5, CSS3 &amp; ES6+ JS.</a:t>
+            </a:r>
+          </a:p>
+          <a:p>
+            <a:pPr>
+              <a:spcAft>
+                <a:spcPts val="800"/>
+              </a:spcAft>
+              <a:defRPr sz="1500">
+                <a:solidFill>
+                  <a:srgbClr val="0F172A"/>
+                </a:solidFill>
+              </a:defRPr>
+            </a:pPr>
+            <a:r>
+              <a:t>•  Key Prototype Modules:</a:t>
+            </a:r>
+          </a:p>
+          <a:p>
+            <a:pPr>
+              <a:spcAft>
+                <a:spcPts val="800"/>
+              </a:spcAft>
+              <a:defRPr sz="1500">
+                <a:solidFill>
+                  <a:srgbClr val="0F172A"/>
+                </a:solidFill>
+              </a:defRPr>
+            </a:pPr>
+            <a:r>
+              <a:t>•    ✔ Live Search &amp; Category Filtering (Textbooks, Calculators, Lab Coats, Dev Boards).</a:t>
+            </a:r>
+          </a:p>
+          <a:p>
+            <a:pPr>
+              <a:spcAft>
+                <a:spcPts val="800"/>
+              </a:spcAft>
+              <a:defRPr sz="1500">
+                <a:solidFill>
+                  <a:srgbClr val="0F172A"/>
+                </a:solidFill>
+              </a:defRPr>
+            </a:pPr>
+            <a:r>
+              <a:t>•    ✔ Instant Mode Switcher (All / Borrow / Rent / Buy).</a:t>
+            </a:r>
+          </a:p>
+          <a:p>
+            <a:pPr>
+              <a:spcAft>
+                <a:spcPts val="800"/>
+              </a:spcAft>
+              <a:defRPr sz="1500">
+                <a:solidFill>
+                  <a:srgbClr val="0F172A"/>
+                </a:solidFill>
+              </a:defRPr>
+            </a:pPr>
+            <a:r>
+              <a:t>•    ✔ Listing Creator Modal: Seniors publish items in 30 seconds with photos &amp; pickup spots.</a:t>
+            </a:r>
+          </a:p>
+          <a:p>
+            <a:pPr>
+              <a:spcAft>
+                <a:spcPts val="800"/>
+              </a:spcAft>
+              <a:defRPr sz="1500">
+                <a:solidFill>
+                  <a:srgbClr val="0F172A"/>
+                </a:solidFill>
+              </a:defRPr>
+            </a:pPr>
+            <a:r>
+              <a:t>•    ✔ Automated Peer Request Modal: Notifies lender with suggested handover meeting.</a:t>
+            </a:r>
+          </a:p>
+          <a:p>
+            <a:pPr>
+              <a:spcAft>
+                <a:spcPts val="800"/>
+              </a:spcAft>
+              <a:defRPr sz="1500">
+                <a:solidFill>
+                  <a:srgbClr val="0F172A"/>
+                </a:solidFill>
+              </a:defRPr>
+            </a:pPr>
+            <a:r>
+              <a:t>•    ✔ Sustainability Tracking: Recirculates idle items and protects pocket money with 0% platform fee.</a:t>
+            </a:r>
+          </a:p>
+        </p:txBody>
+      </p:sp>
+      <p:pic>
+        <p:nvPicPr>
+          <p:cNvPr id="261" name="Picture 260" descr="image.png"/>
+          <p:cNvPicPr>
+            <a:picLocks noChangeAspect="1"/>
+          </p:cNvPicPr>
+          <p:nvPr/>
+        </p:nvPicPr>
+        <p:blipFill>
+          <a:blip r:embed="rId12"/>
+          <a:stretch>
+            <a:fillRect/>
+          </a:stretch>
+        </p:blipFill>
+        <p:spPr>
+          <a:xfrm>
+            <a:off x="19000000" y="21500000"/>
+            <a:ext cx="15500000" cy="5200000"/>
+          </a:xfrm>
+          <a:prstGeom prst="rect">
+            <a:avLst/>
+          </a:prstGeom>
+        </p:spPr>
+      </p:pic>
+      <p:sp>
+        <p:nvSpPr>
+          <p:cNvPr id="262" name="Rounded Rectangle 261"/>
           <p:cNvSpPr/>
           <p:nvPr/>
         </p:nvSpPr>

</xml_diff>

<commit_message>
feat: add Priyansh Kashyap (CSE AI | 235890468) and Sridhar Madhira across all project deliverables, slides, report, and script
</commit_message>
<xml_diff>
--- a/Design Thinking Poster.pptx
+++ b/Design Thinking Poster.pptx
@@ -13056,7 +13056,7 @@
               </a:defRPr>
             </a:pPr>
             <a:r>
-              <a:t>Team Members: [Team Member 1 | Team Member 2]  •  Reg Nos: [2309xxxxx | 2309xxxxx]</a:t>
+              <a:t>Team Members: Sridhar Madhira | Priyansh Kashyap [CSE (AI)]  •  Reg Nos: [Your Reg No] | 235890468</a:t>
             </a:r>
           </a:p>
           <a:p>
@@ -26305,6 +26305,855 @@
       <p:sp>
         <p:nvSpPr>
           <p:cNvPr id="262" name="Rounded Rectangle 261"/>
+          <p:cNvSpPr/>
+          <p:nvPr/>
+        </p:nvSpPr>
+        <p:spPr>
+          <a:xfrm>
+            <a:off x="18500000" y="28500000"/>
+            <a:ext cx="16500000" cy="6800000"/>
+          </a:xfrm>
+          <a:prstGeom prst="roundRect">
+            <a:avLst/>
+          </a:prstGeom>
+          <a:solidFill>
+            <a:srgbClr val="FFFFFF"/>
+          </a:solidFill>
+          <a:ln w="25400">
+            <a:solidFill>
+              <a:srgbClr val="CBD5E1"/>
+            </a:solidFill>
+          </a:ln>
+        </p:spPr>
+        <p:style>
+          <a:lnRef idx="1">
+            <a:schemeClr val="accent1"/>
+          </a:lnRef>
+          <a:fillRef idx="3">
+            <a:schemeClr val="accent1"/>
+          </a:fillRef>
+          <a:effectRef idx="2">
+            <a:schemeClr val="accent1"/>
+          </a:effectRef>
+          <a:fontRef idx="minor">
+            <a:schemeClr val="lt1"/>
+          </a:fontRef>
+        </p:style>
+        <p:txBody>
+          <a:bodyPr rtlCol="0" anchor="ctr" wrap="square" lIns="182880" tIns="182880" rIns="182880" bIns="182880"/>
+          <a:lstStyle/>
+          <a:p>
+            <a:pPr algn="ctr">
+              <a:spcAft>
+                <a:spcPts val="1200"/>
+              </a:spcAft>
+              <a:defRPr sz="2200" b="1">
+                <a:solidFill>
+                  <a:srgbClr val="2563EB"/>
+                </a:solidFill>
+              </a:defRPr>
+            </a:pPr>
+            <a:r>
+              <a:t>OUTCOME &amp; IMPACT</a:t>
+            </a:r>
+          </a:p>
+          <a:p>
+            <a:pPr>
+              <a:spcAft>
+                <a:spcPts val="800"/>
+              </a:spcAft>
+              <a:defRPr sz="1500">
+                <a:solidFill>
+                  <a:srgbClr val="0F172A"/>
+                </a:solidFill>
+              </a:defRPr>
+            </a:pPr>
+            <a:r>
+              <a:t>•  Peer Walkthrough &amp; Thematic Validation:</a:t>
+            </a:r>
+          </a:p>
+          <a:p>
+            <a:pPr>
+              <a:spcAft>
+                <a:spcPts val="800"/>
+              </a:spcAft>
+              <a:defRPr sz="1500">
+                <a:solidFill>
+                  <a:srgbClr val="0F172A"/>
+                </a:solidFill>
+              </a:defRPr>
+            </a:pPr>
+            <a:r>
+              <a:t>•    • Zero-Knowledge Safety: Female hostel students praised complete concealment of phone numbers &amp; room details.</a:t>
+            </a:r>
+          </a:p>
+          <a:p>
+            <a:pPr>
+              <a:spcAft>
+                <a:spcPts val="800"/>
+              </a:spcAft>
+              <a:defRPr sz="1500">
+                <a:solidFill>
+                  <a:srgbClr val="0F172A"/>
+                </a:solidFill>
+              </a:defRPr>
+            </a:pPr>
+            <a:r>
+              <a:t>•    • On-Spot UPI Trust: Direct scan-and-pay eliminates fear of advance app escrow lock-in.</a:t>
+            </a:r>
+          </a:p>
+          <a:p>
+            <a:pPr>
+              <a:spcAft>
+                <a:spcPts val="800"/>
+              </a:spcAft>
+              <a:defRPr sz="1500">
+                <a:solidFill>
+                  <a:srgbClr val="0F172A"/>
+                </a:solidFill>
+              </a:defRPr>
+            </a:pPr>
+            <a:r>
+              <a:t>•    • Transparent Fixed Pricing: Freshers confirmed total relief from opaque 'DM for price' culture.</a:t>
+            </a:r>
+          </a:p>
+          <a:p>
+            <a:pPr>
+              <a:spcAft>
+                <a:spcPts val="800"/>
+              </a:spcAft>
+              <a:defRPr sz="1500">
+                <a:solidFill>
+                  <a:srgbClr val="0F172A"/>
+                </a:solidFill>
+              </a:defRPr>
+            </a:pPr>
+            <a:r>
+              <a:t>•  Campus Impact: Prevents recurring spending on 1-semester gear and recirculates idle resources within MIT Bengaluru.</a:t>
+            </a:r>
+          </a:p>
+          <a:p>
+            <a:pPr>
+              <a:spcAft>
+                <a:spcPts val="800"/>
+              </a:spcAft>
+              <a:defRPr sz="1500">
+                <a:solidFill>
+                  <a:srgbClr val="0F172A"/>
+                </a:solidFill>
+              </a:defRPr>
+            </a:pPr>
+            <a:r>
+              <a:t>•  Future Roadmap: WhatsApp Cloud API alerts, campus locker integration, and library reserve sync.</a:t>
+            </a:r>
+          </a:p>
+        </p:txBody>
+      </p:sp>
+      <p:sp>
+        <p:nvSpPr>
+          <p:cNvPr id="263" name="Rounded Rectangle 262"/>
+          <p:cNvSpPr/>
+          <p:nvPr/>
+        </p:nvSpPr>
+        <p:spPr>
+          <a:xfrm>
+            <a:off x="1000000" y="5800000"/>
+            <a:ext cx="16500000" cy="19000000"/>
+          </a:xfrm>
+          <a:prstGeom prst="roundRect">
+            <a:avLst/>
+          </a:prstGeom>
+          <a:solidFill>
+            <a:srgbClr val="FFFFFF"/>
+          </a:solidFill>
+          <a:ln w="25400">
+            <a:solidFill>
+              <a:srgbClr val="CBD5E1"/>
+            </a:solidFill>
+          </a:ln>
+        </p:spPr>
+        <p:style>
+          <a:lnRef idx="1">
+            <a:schemeClr val="accent1"/>
+          </a:lnRef>
+          <a:fillRef idx="3">
+            <a:schemeClr val="accent1"/>
+          </a:fillRef>
+          <a:effectRef idx="2">
+            <a:schemeClr val="accent1"/>
+          </a:effectRef>
+          <a:fontRef idx="minor">
+            <a:schemeClr val="lt1"/>
+          </a:fontRef>
+        </p:style>
+        <p:txBody>
+          <a:bodyPr rtlCol="0" anchor="ctr" wrap="square" lIns="182880" tIns="182880" rIns="182880" bIns="182880"/>
+          <a:lstStyle/>
+          <a:p>
+            <a:pPr algn="ctr">
+              <a:spcAft>
+                <a:spcPts val="1200"/>
+              </a:spcAft>
+              <a:defRPr sz="2200" b="1">
+                <a:solidFill>
+                  <a:srgbClr val="2563EB"/>
+                </a:solidFill>
+              </a:defRPr>
+            </a:pPr>
+            <a:r>
+              <a:t>PHASE 1: EMPATHY &amp; OBJECTIVE</a:t>
+            </a:r>
+          </a:p>
+          <a:p>
+            <a:pPr>
+              <a:spcAft>
+                <a:spcPts val="800"/>
+              </a:spcAft>
+              <a:defRPr sz="1500">
+                <a:solidFill>
+                  <a:srgbClr val="0F172A"/>
+                </a:solidFill>
+              </a:defRPr>
+            </a:pPr>
+            <a:r>
+              <a:t>•  Project Objective: Create a zero-friction, verified circular exchange platform allowing engineering students to Borrow, Rent, or Buy single-semester academic gear (textbooks, Casio fx-991 calculators, lab coats, drafters) from seniors at near-zero cost.</a:t>
+            </a:r>
+          </a:p>
+          <a:p>
+            <a:pPr>
+              <a:spcAft>
+                <a:spcPts val="800"/>
+              </a:spcAft>
+              <a:defRPr sz="1500">
+                <a:solidFill>
+                  <a:srgbClr val="0F172A"/>
+                </a:solidFill>
+              </a:defRPr>
+            </a:pPr>
+            <a:r>
+              <a:t>•  Qualitative Field Insights (MIT Bengaluru Campus):</a:t>
+            </a:r>
+          </a:p>
+          <a:p>
+            <a:pPr>
+              <a:spcAft>
+                <a:spcPts val="800"/>
+              </a:spcAft>
+              <a:defRPr sz="1500">
+                <a:solidFill>
+                  <a:srgbClr val="0F172A"/>
+                </a:solidFill>
+              </a:defRPr>
+            </a:pPr>
+            <a:r>
+              <a:t>•    - 88% of freshers spend ₹2,500–₹4,500 every semester on specialized gear used for only 16 weeks.</a:t>
+            </a:r>
+          </a:p>
+          <a:p>
+            <a:pPr>
+              <a:spcAft>
+                <a:spcPts val="800"/>
+              </a:spcAft>
+              <a:defRPr sz="1500">
+                <a:solidFill>
+                  <a:srgbClr val="0F172A"/>
+                </a:solidFill>
+              </a:defRPr>
+            </a:pPr>
+            <a:r>
+              <a:t>•    - 92% of seniors have 3+ textbooks &amp; tools sitting idle in hostel cupboards with no easy way to transfer them.</a:t>
+            </a:r>
+          </a:p>
+          <a:p>
+            <a:pPr>
+              <a:spcAft>
+                <a:spcPts val="800"/>
+              </a:spcAft>
+              <a:defRPr sz="1500">
+                <a:solidFill>
+                  <a:srgbClr val="0F172A"/>
+                </a:solidFill>
+              </a:defRPr>
+            </a:pPr>
+            <a:r>
+              <a:t>•    - Existing WhatsApp groups fail: notices get buried under hundreds of messages within 15 minutes.</a:t>
+            </a:r>
+          </a:p>
+          <a:p>
+            <a:pPr>
+              <a:spcAft>
+                <a:spcPts val="800"/>
+              </a:spcAft>
+              <a:defRPr sz="1500">
+                <a:solidFill>
+                  <a:srgbClr val="0F172A"/>
+                </a:solidFill>
+              </a:defRPr>
+            </a:pPr>
+            <a:r>
+              <a:t>•  Customer Journey Mapping Highlights:</a:t>
+            </a:r>
+          </a:p>
+          <a:p>
+            <a:pPr>
+              <a:spcAft>
+                <a:spcPts val="800"/>
+              </a:spcAft>
+              <a:defRPr sz="1500">
+                <a:solidFill>
+                  <a:srgbClr val="0F172A"/>
+                </a:solidFill>
+              </a:defRPr>
+            </a:pPr>
+            <a:r>
+              <a:t>•    - Touchpoints: Syllabus release -&gt; WhatsApp panic -&gt; Senior negotiation -&gt; Handover friction -&gt; Disposal.</a:t>
+            </a:r>
+          </a:p>
+          <a:p>
+            <a:pPr>
+              <a:spcAft>
+                <a:spcPts val="800"/>
+              </a:spcAft>
+              <a:defRPr sz="1500">
+                <a:solidFill>
+                  <a:srgbClr val="0F172A"/>
+                </a:solidFill>
+              </a:defRPr>
+            </a:pPr>
+            <a:r>
+              <a:t>•    - Emotional Dip: High anxiety during 1st month due to unexpected equipment expenses.</a:t>
+            </a:r>
+          </a:p>
+          <a:p>
+            <a:pPr>
+              <a:spcAft>
+                <a:spcPts val="800"/>
+              </a:spcAft>
+              <a:defRPr sz="1500">
+                <a:solidFill>
+                  <a:srgbClr val="0F172A"/>
+                </a:solidFill>
+              </a:defRPr>
+            </a:pPr>
+            <a:r>
+              <a:t>•  Problem Statement: Freshers face recurring financial burdens while seniors hoard unused academic supplies, caused by the absence of a structured, campus-verified peer-to-peer exchange.</a:t>
+            </a:r>
+          </a:p>
+        </p:txBody>
+      </p:sp>
+      <p:sp>
+        <p:nvSpPr>
+          <p:cNvPr id="264" name="Rounded Rectangle 263"/>
+          <p:cNvSpPr/>
+          <p:nvPr/>
+        </p:nvSpPr>
+        <p:spPr>
+          <a:xfrm>
+            <a:off x="1000000" y="26800000"/>
+            <a:ext cx="16500000" cy="8500000"/>
+          </a:xfrm>
+          <a:prstGeom prst="roundRect">
+            <a:avLst/>
+          </a:prstGeom>
+          <a:solidFill>
+            <a:srgbClr val="FFFFFF"/>
+          </a:solidFill>
+          <a:ln w="25400">
+            <a:solidFill>
+              <a:srgbClr val="CBD5E1"/>
+            </a:solidFill>
+          </a:ln>
+        </p:spPr>
+        <p:style>
+          <a:lnRef idx="1">
+            <a:schemeClr val="accent1"/>
+          </a:lnRef>
+          <a:fillRef idx="3">
+            <a:schemeClr val="accent1"/>
+          </a:fillRef>
+          <a:effectRef idx="2">
+            <a:schemeClr val="accent1"/>
+          </a:effectRef>
+          <a:fontRef idx="minor">
+            <a:schemeClr val="lt1"/>
+          </a:fontRef>
+        </p:style>
+        <p:txBody>
+          <a:bodyPr rtlCol="0" anchor="ctr" wrap="square" lIns="182880" tIns="182880" rIns="182880" bIns="182880"/>
+          <a:lstStyle/>
+          <a:p>
+            <a:pPr algn="ctr">
+              <a:spcAft>
+                <a:spcPts val="1200"/>
+              </a:spcAft>
+              <a:defRPr sz="2200" b="1">
+                <a:solidFill>
+                  <a:srgbClr val="2563EB"/>
+                </a:solidFill>
+              </a:defRPr>
+            </a:pPr>
+            <a:r>
+              <a:t>PHASE 2: ANALYSE &amp; ROOT CAUSE</a:t>
+            </a:r>
+          </a:p>
+          <a:p>
+            <a:pPr>
+              <a:spcAft>
+                <a:spcPts val="800"/>
+              </a:spcAft>
+              <a:defRPr sz="1500">
+                <a:solidFill>
+                  <a:srgbClr val="0F172A"/>
+                </a:solidFill>
+              </a:defRPr>
+            </a:pPr>
+            <a:r>
+              <a:t>•  5-Whys Root Cause Analysis:</a:t>
+            </a:r>
+          </a:p>
+          <a:p>
+            <a:pPr>
+              <a:spcAft>
+                <a:spcPts val="800"/>
+              </a:spcAft>
+              <a:defRPr sz="1500">
+                <a:solidFill>
+                  <a:srgbClr val="0F172A"/>
+                </a:solidFill>
+              </a:defRPr>
+            </a:pPr>
+            <a:r>
+              <a:t>•    1. Why do freshers overspend on tools? They buy brand new items from external stores.</a:t>
+            </a:r>
+          </a:p>
+          <a:p>
+            <a:pPr>
+              <a:spcAft>
+                <a:spcPts val="800"/>
+              </a:spcAft>
+              <a:defRPr sz="1500">
+                <a:solidFill>
+                  <a:srgbClr val="0F172A"/>
+                </a:solidFill>
+              </a:defRPr>
+            </a:pPr>
+            <a:r>
+              <a:t>•    2. Why don't they get them from seniors? Unused items remain locked in seniors' hostel rooms.</a:t>
+            </a:r>
+          </a:p>
+          <a:p>
+            <a:pPr>
+              <a:spcAft>
+                <a:spcPts val="800"/>
+              </a:spcAft>
+              <a:defRPr sz="1500">
+                <a:solidFill>
+                  <a:srgbClr val="0F172A"/>
+                </a:solidFill>
+              </a:defRPr>
+            </a:pPr>
+            <a:r>
+              <a:t>•    3. Why don't seniors sell or lend them? Informal posting on social media is cumbersome and unorganized.</a:t>
+            </a:r>
+          </a:p>
+          <a:p>
+            <a:pPr>
+              <a:spcAft>
+                <a:spcPts val="800"/>
+              </a:spcAft>
+              <a:defRPr sz="1500">
+                <a:solidFill>
+                  <a:srgbClr val="0F172A"/>
+                </a:solidFill>
+              </a:defRPr>
+            </a:pPr>
+            <a:r>
+              <a:t>•    4. Why are chat groups inefficient? No search filters, item categories, or availability tracking.</a:t>
+            </a:r>
+          </a:p>
+          <a:p>
+            <a:pPr>
+              <a:spcAft>
+                <a:spcPts val="800"/>
+              </a:spcAft>
+              <a:defRPr sz="1500">
+                <a:solidFill>
+                  <a:srgbClr val="0F172A"/>
+                </a:solidFill>
+              </a:defRPr>
+            </a:pPr>
+            <a:r>
+              <a:t>•    5. Root Cause: Lack of a dedicated, campus-verified web portal facilitating discovery and peer handover.</a:t>
+            </a:r>
+          </a:p>
+          <a:p>
+            <a:pPr>
+              <a:spcAft>
+                <a:spcPts val="800"/>
+              </a:spcAft>
+              <a:defRPr sz="1500">
+                <a:solidFill>
+                  <a:srgbClr val="0F172A"/>
+                </a:solidFill>
+              </a:defRPr>
+            </a:pPr>
+            <a:r>
+              <a:t>•  How Might We (HMW) Question:</a:t>
+            </a:r>
+          </a:p>
+          <a:p>
+            <a:pPr>
+              <a:spcAft>
+                <a:spcPts val="800"/>
+              </a:spcAft>
+              <a:defRPr sz="1500">
+                <a:solidFill>
+                  <a:srgbClr val="0F172A"/>
+                </a:solidFill>
+              </a:defRPr>
+            </a:pPr>
+            <a:r>
+              <a:t>•    'How might we connect junior and senior students for safe, verified, zero-commission exchange of academic resources at designated campus landmarks?'</a:t>
+            </a:r>
+          </a:p>
+        </p:txBody>
+      </p:sp>
+      <p:sp>
+        <p:nvSpPr>
+          <p:cNvPr id="265" name="Rounded Rectangle 264"/>
+          <p:cNvSpPr/>
+          <p:nvPr/>
+        </p:nvSpPr>
+        <p:spPr>
+          <a:xfrm>
+            <a:off x="18500000" y="5800000"/>
+            <a:ext cx="16500000" cy="7200000"/>
+          </a:xfrm>
+          <a:prstGeom prst="roundRect">
+            <a:avLst/>
+          </a:prstGeom>
+          <a:solidFill>
+            <a:srgbClr val="FFFFFF"/>
+          </a:solidFill>
+          <a:ln w="25400">
+            <a:solidFill>
+              <a:srgbClr val="CBD5E1"/>
+            </a:solidFill>
+          </a:ln>
+        </p:spPr>
+        <p:style>
+          <a:lnRef idx="1">
+            <a:schemeClr val="accent1"/>
+          </a:lnRef>
+          <a:fillRef idx="3">
+            <a:schemeClr val="accent1"/>
+          </a:fillRef>
+          <a:effectRef idx="2">
+            <a:schemeClr val="accent1"/>
+          </a:effectRef>
+          <a:fontRef idx="minor">
+            <a:schemeClr val="lt1"/>
+          </a:fontRef>
+        </p:style>
+        <p:txBody>
+          <a:bodyPr rtlCol="0" anchor="ctr" wrap="square" lIns="182880" tIns="182880" rIns="182880" bIns="182880"/>
+          <a:lstStyle/>
+          <a:p>
+            <a:pPr algn="ctr">
+              <a:spcAft>
+                <a:spcPts val="1200"/>
+              </a:spcAft>
+              <a:defRPr sz="2200" b="1">
+                <a:solidFill>
+                  <a:srgbClr val="2563EB"/>
+                </a:solidFill>
+              </a:defRPr>
+            </a:pPr>
+            <a:r>
+              <a:t>PHASE 3: SOLVE &amp; KEY FEATURES</a:t>
+            </a:r>
+          </a:p>
+          <a:p>
+            <a:pPr>
+              <a:spcAft>
+                <a:spcPts val="800"/>
+              </a:spcAft>
+              <a:defRPr sz="1500">
+                <a:solidFill>
+                  <a:srgbClr val="0F172A"/>
+                </a:solidFill>
+              </a:defRPr>
+            </a:pPr>
+            <a:r>
+              <a:t>•  Multi-Tier Exchange Mechanism:</a:t>
+            </a:r>
+          </a:p>
+          <a:p>
+            <a:pPr>
+              <a:spcAft>
+                <a:spcPts val="800"/>
+              </a:spcAft>
+              <a:defRPr sz="1500">
+                <a:solidFill>
+                  <a:srgbClr val="0F172A"/>
+                </a:solidFill>
+              </a:defRPr>
+            </a:pPr>
+            <a:r>
+              <a:t>•    • Borrow (Free): 1-semester loan with return guarantee (e.g. Higher Engg Math).</a:t>
+            </a:r>
+          </a:p>
+          <a:p>
+            <a:pPr>
+              <a:spcAft>
+                <a:spcPts val="800"/>
+              </a:spcAft>
+              <a:defRPr sz="1500">
+                <a:solidFill>
+                  <a:srgbClr val="0F172A"/>
+                </a:solidFill>
+              </a:defRPr>
+            </a:pPr>
+            <a:r>
+              <a:t>•    • Rent (Low-Cost): Weekly rentals (₹20-50/wk) for exam prep (e.g. Casio fx-991).</a:t>
+            </a:r>
+          </a:p>
+          <a:p>
+            <a:pPr>
+              <a:spcAft>
+                <a:spcPts val="800"/>
+              </a:spcAft>
+              <a:defRPr sz="1500">
+                <a:solidFill>
+                  <a:srgbClr val="0F172A"/>
+                </a:solidFill>
+              </a:defRPr>
+            </a:pPr>
+            <a:r>
+              <a:t>•    • Buy (75% Off): Permanent transfer at deep discount (e.g. Mini Drafters, CLRS).</a:t>
+            </a:r>
+          </a:p>
+          <a:p>
+            <a:pPr>
+              <a:spcAft>
+                <a:spcPts val="800"/>
+              </a:spcAft>
+              <a:defRPr sz="1500">
+                <a:solidFill>
+                  <a:srgbClr val="0F172A"/>
+                </a:solidFill>
+              </a:defRPr>
+            </a:pPr>
+            <a:r>
+              <a:t>•  Verified Campus Security: Restricted to @learner.manipal.edu credentials.</a:t>
+            </a:r>
+          </a:p>
+          <a:p>
+            <a:pPr>
+              <a:spcAft>
+                <a:spcPts val="800"/>
+              </a:spcAft>
+              <a:defRPr sz="1500">
+                <a:solidFill>
+                  <a:srgbClr val="0F172A"/>
+                </a:solidFill>
+              </a:defRPr>
+            </a:pPr>
+            <a:r>
+              <a:t>•  Zero Courier Delay: Handovers coordinated at Central Library &amp; Food Court.</a:t>
+            </a:r>
+          </a:p>
+        </p:txBody>
+      </p:sp>
+      <p:sp>
+        <p:nvSpPr>
+          <p:cNvPr id="266" name="Rounded Rectangle 265"/>
+          <p:cNvSpPr/>
+          <p:nvPr/>
+        </p:nvSpPr>
+        <p:spPr>
+          <a:xfrm>
+            <a:off x="18500000" y="14500000"/>
+            <a:ext cx="16500000" cy="12500000"/>
+          </a:xfrm>
+          <a:prstGeom prst="roundRect">
+            <a:avLst/>
+          </a:prstGeom>
+          <a:solidFill>
+            <a:srgbClr val="FFFFFF"/>
+          </a:solidFill>
+          <a:ln w="25400">
+            <a:solidFill>
+              <a:srgbClr val="CBD5E1"/>
+            </a:solidFill>
+          </a:ln>
+        </p:spPr>
+        <p:style>
+          <a:lnRef idx="1">
+            <a:schemeClr val="accent1"/>
+          </a:lnRef>
+          <a:fillRef idx="3">
+            <a:schemeClr val="accent1"/>
+          </a:fillRef>
+          <a:effectRef idx="2">
+            <a:schemeClr val="accent1"/>
+          </a:effectRef>
+          <a:fontRef idx="minor">
+            <a:schemeClr val="lt1"/>
+          </a:fontRef>
+        </p:style>
+        <p:txBody>
+          <a:bodyPr rtlCol="0" anchor="ctr" wrap="square" lIns="182880" tIns="182880" rIns="182880" bIns="182880"/>
+          <a:lstStyle/>
+          <a:p>
+            <a:pPr algn="ctr">
+              <a:spcAft>
+                <a:spcPts val="1200"/>
+              </a:spcAft>
+              <a:defRPr sz="2200" b="1">
+                <a:solidFill>
+                  <a:srgbClr val="2563EB"/>
+                </a:solidFill>
+              </a:defRPr>
+            </a:pPr>
+            <a:r>
+              <a:t>PHASE 4: PROTOTYPE IMPLEMENTATION</a:t>
+            </a:r>
+          </a:p>
+          <a:p>
+            <a:pPr>
+              <a:spcAft>
+                <a:spcPts val="800"/>
+              </a:spcAft>
+              <a:defRPr sz="1500">
+                <a:solidFill>
+                  <a:srgbClr val="0F172A"/>
+                </a:solidFill>
+              </a:defRPr>
+            </a:pPr>
+            <a:r>
+              <a:t>•  Interactive Web Application Built with Semantic HTML5, CSS3 &amp; ES6+ JS.</a:t>
+            </a:r>
+          </a:p>
+          <a:p>
+            <a:pPr>
+              <a:spcAft>
+                <a:spcPts val="800"/>
+              </a:spcAft>
+              <a:defRPr sz="1500">
+                <a:solidFill>
+                  <a:srgbClr val="0F172A"/>
+                </a:solidFill>
+              </a:defRPr>
+            </a:pPr>
+            <a:r>
+              <a:t>•  Key Prototype Modules:</a:t>
+            </a:r>
+          </a:p>
+          <a:p>
+            <a:pPr>
+              <a:spcAft>
+                <a:spcPts val="800"/>
+              </a:spcAft>
+              <a:defRPr sz="1500">
+                <a:solidFill>
+                  <a:srgbClr val="0F172A"/>
+                </a:solidFill>
+              </a:defRPr>
+            </a:pPr>
+            <a:r>
+              <a:t>•    ✔ Live Search &amp; Category Filtering (Textbooks, Calculators, Lab Coats, Dev Boards).</a:t>
+            </a:r>
+          </a:p>
+          <a:p>
+            <a:pPr>
+              <a:spcAft>
+                <a:spcPts val="800"/>
+              </a:spcAft>
+              <a:defRPr sz="1500">
+                <a:solidFill>
+                  <a:srgbClr val="0F172A"/>
+                </a:solidFill>
+              </a:defRPr>
+            </a:pPr>
+            <a:r>
+              <a:t>•    ✔ Instant Mode Switcher (All / Borrow / Rent / Buy).</a:t>
+            </a:r>
+          </a:p>
+          <a:p>
+            <a:pPr>
+              <a:spcAft>
+                <a:spcPts val="800"/>
+              </a:spcAft>
+              <a:defRPr sz="1500">
+                <a:solidFill>
+                  <a:srgbClr val="0F172A"/>
+                </a:solidFill>
+              </a:defRPr>
+            </a:pPr>
+            <a:r>
+              <a:t>•    ✔ Listing Creator Modal: Seniors publish items in 30 seconds with photos &amp; pickup spots.</a:t>
+            </a:r>
+          </a:p>
+          <a:p>
+            <a:pPr>
+              <a:spcAft>
+                <a:spcPts val="800"/>
+              </a:spcAft>
+              <a:defRPr sz="1500">
+                <a:solidFill>
+                  <a:srgbClr val="0F172A"/>
+                </a:solidFill>
+              </a:defRPr>
+            </a:pPr>
+            <a:r>
+              <a:t>•    ✔ Automated Peer Request Modal: Notifies lender with suggested handover meeting.</a:t>
+            </a:r>
+          </a:p>
+          <a:p>
+            <a:pPr>
+              <a:spcAft>
+                <a:spcPts val="800"/>
+              </a:spcAft>
+              <a:defRPr sz="1500">
+                <a:solidFill>
+                  <a:srgbClr val="0F172A"/>
+                </a:solidFill>
+              </a:defRPr>
+            </a:pPr>
+            <a:r>
+              <a:t>•    ✔ Sustainability Tracking: Recirculates idle items and protects pocket money with 0% platform fee.</a:t>
+            </a:r>
+          </a:p>
+        </p:txBody>
+      </p:sp>
+      <p:pic>
+        <p:nvPicPr>
+          <p:cNvPr id="267" name="Picture 266" descr="image.png"/>
+          <p:cNvPicPr>
+            <a:picLocks noChangeAspect="1"/>
+          </p:cNvPicPr>
+          <p:nvPr/>
+        </p:nvPicPr>
+        <p:blipFill>
+          <a:blip r:embed="rId12"/>
+          <a:stretch>
+            <a:fillRect/>
+          </a:stretch>
+        </p:blipFill>
+        <p:spPr>
+          <a:xfrm>
+            <a:off x="19000000" y="21500000"/>
+            <a:ext cx="15500000" cy="5200000"/>
+          </a:xfrm>
+          <a:prstGeom prst="rect">
+            <a:avLst/>
+          </a:prstGeom>
+        </p:spPr>
+      </p:pic>
+      <p:sp>
+        <p:nvSpPr>
+          <p:cNvPr id="268" name="Rounded Rectangle 267"/>
           <p:cNvSpPr/>
           <p:nvPr/>
         </p:nvSpPr>

</xml_diff>